<commit_message>
ask not what your company can do for you...
</commit_message>
<xml_diff>
--- a/Recipe for Success in IT.pptx
+++ b/Recipe for Success in IT.pptx
@@ -307,7 +307,7 @@
           <a:p>
             <a:fld id="{58752A94-428C-467F-AD43-B3FAA28FBF5A}" type="datetimeFigureOut">
               <a:rPr lang="en-US" smtClean="0"/>
-              <a:t>11/19/2018</a:t>
+              <a:t>5/17/2025</a:t>
             </a:fld>
             <a:endParaRPr lang="en-US"/>
           </a:p>
@@ -860,6 +860,46 @@
               <a:tabLst/>
               <a:defRPr/>
             </a:pPr>
+            <a:r>
+              <a:rPr lang="en-US" sz="1200" b="1" dirty="0">
+                <a:solidFill>
+                  <a:schemeClr val="bg1"/>
+                </a:solidFill>
+              </a:rPr>
+              <a:t>Ask not what your company can do for you, ask what you can do for </a:t>
+            </a:r>
+            <a:r>
+              <a:rPr lang="en-US" sz="1200" b="1">
+                <a:solidFill>
+                  <a:schemeClr val="bg1"/>
+                </a:solidFill>
+              </a:rPr>
+              <a:t>your company!</a:t>
+            </a:r>
+            <a:endParaRPr lang="en-US" sz="1200" b="1" dirty="0">
+              <a:solidFill>
+                <a:schemeClr val="bg1"/>
+              </a:solidFill>
+            </a:endParaRPr>
+          </a:p>
+          <a:p>
+            <a:pPr marL="0" marR="0" lvl="0" indent="0" algn="l" defTabSz="914400" rtl="0" eaLnBrk="1" fontAlgn="auto" latinLnBrk="0" hangingPunct="1">
+              <a:lnSpc>
+                <a:spcPct val="100000"/>
+              </a:lnSpc>
+              <a:spcBef>
+                <a:spcPts val="0"/>
+              </a:spcBef>
+              <a:spcAft>
+                <a:spcPts val="0"/>
+              </a:spcAft>
+              <a:buClrTx/>
+              <a:buSzTx/>
+              <a:buFontTx/>
+              <a:buNone/>
+              <a:tabLst/>
+              <a:defRPr/>
+            </a:pPr>
             <a:endParaRPr lang="en-US" dirty="0"/>
           </a:p>
         </p:txBody>
@@ -3203,7 +3243,7 @@
             <a:fld id="{B61BEF0D-F0BB-DE4B-95CE-6DB70DBA9567}" type="datetimeFigureOut">
               <a:rPr lang="en-US" dirty="0"/>
               <a:pPr/>
-              <a:t>11/19/2018</a:t>
+              <a:t>5/17/2025</a:t>
             </a:fld>
             <a:endParaRPr lang="en-US" dirty="0"/>
           </a:p>
@@ -3636,7 +3676,7 @@
             <a:fld id="{B61BEF0D-F0BB-DE4B-95CE-6DB70DBA9567}" type="datetimeFigureOut">
               <a:rPr lang="en-US" dirty="0"/>
               <a:pPr/>
-              <a:t>11/19/2018</a:t>
+              <a:t>5/17/2025</a:t>
             </a:fld>
             <a:endParaRPr lang="en-US" dirty="0"/>
           </a:p>
@@ -3883,7 +3923,7 @@
             <a:fld id="{B61BEF0D-F0BB-DE4B-95CE-6DB70DBA9567}" type="datetimeFigureOut">
               <a:rPr lang="en-US" dirty="0"/>
               <a:pPr/>
-              <a:t>11/19/2018</a:t>
+              <a:t>5/17/2025</a:t>
             </a:fld>
             <a:endParaRPr lang="en-US" dirty="0"/>
           </a:p>
@@ -4188,7 +4228,7 @@
             <a:fld id="{B61BEF0D-F0BB-DE4B-95CE-6DB70DBA9567}" type="datetimeFigureOut">
               <a:rPr lang="en-US" dirty="0"/>
               <a:pPr/>
-              <a:t>11/19/2018</a:t>
+              <a:t>5/17/2025</a:t>
             </a:fld>
             <a:endParaRPr lang="en-US" dirty="0"/>
           </a:p>
@@ -4503,7 +4543,7 @@
             <a:fld id="{B61BEF0D-F0BB-DE4B-95CE-6DB70DBA9567}" type="datetimeFigureOut">
               <a:rPr lang="en-US" dirty="0"/>
               <a:pPr/>
-              <a:t>11/19/2018</a:t>
+              <a:t>5/17/2025</a:t>
             </a:fld>
             <a:endParaRPr lang="en-US" dirty="0"/>
           </a:p>
@@ -4802,7 +4842,7 @@
             <a:fld id="{B61BEF0D-F0BB-DE4B-95CE-6DB70DBA9567}" type="datetimeFigureOut">
               <a:rPr lang="en-US" dirty="0"/>
               <a:pPr/>
-              <a:t>11/19/2018</a:t>
+              <a:t>5/17/2025</a:t>
             </a:fld>
             <a:endParaRPr lang="en-US" dirty="0"/>
           </a:p>
@@ -5166,7 +5206,7 @@
             <a:fld id="{B61BEF0D-F0BB-DE4B-95CE-6DB70DBA9567}" type="datetimeFigureOut">
               <a:rPr lang="en-US" dirty="0"/>
               <a:pPr/>
-              <a:t>11/19/2018</a:t>
+              <a:t>5/17/2025</a:t>
             </a:fld>
             <a:endParaRPr lang="en-US" dirty="0"/>
           </a:p>
@@ -5337,7 +5377,7 @@
             <a:fld id="{B61BEF0D-F0BB-DE4B-95CE-6DB70DBA9567}" type="datetimeFigureOut">
               <a:rPr lang="en-US" dirty="0"/>
               <a:pPr/>
-              <a:t>11/19/2018</a:t>
+              <a:t>5/17/2025</a:t>
             </a:fld>
             <a:endParaRPr lang="en-US" dirty="0"/>
           </a:p>
@@ -5514,7 +5554,7 @@
             <a:fld id="{B61BEF0D-F0BB-DE4B-95CE-6DB70DBA9567}" type="datetimeFigureOut">
               <a:rPr lang="en-US" dirty="0"/>
               <a:pPr/>
-              <a:t>11/19/2018</a:t>
+              <a:t>5/17/2025</a:t>
             </a:fld>
             <a:endParaRPr lang="en-US" dirty="0"/>
           </a:p>
@@ -5681,7 +5721,7 @@
             <a:fld id="{B61BEF0D-F0BB-DE4B-95CE-6DB70DBA9567}" type="datetimeFigureOut">
               <a:rPr lang="en-US" dirty="0"/>
               <a:pPr/>
-              <a:t>11/19/2018</a:t>
+              <a:t>5/17/2025</a:t>
             </a:fld>
             <a:endParaRPr lang="en-US" dirty="0"/>
           </a:p>
@@ -5928,7 +5968,7 @@
             <a:fld id="{B61BEF0D-F0BB-DE4B-95CE-6DB70DBA9567}" type="datetimeFigureOut">
               <a:rPr lang="en-US" dirty="0"/>
               <a:pPr/>
-              <a:t>11/19/2018</a:t>
+              <a:t>5/17/2025</a:t>
             </a:fld>
             <a:endParaRPr lang="en-US" dirty="0"/>
           </a:p>
@@ -6161,7 +6201,7 @@
             <a:fld id="{B61BEF0D-F0BB-DE4B-95CE-6DB70DBA9567}" type="datetimeFigureOut">
               <a:rPr lang="en-US" dirty="0"/>
               <a:pPr/>
-              <a:t>11/19/2018</a:t>
+              <a:t>5/17/2025</a:t>
             </a:fld>
             <a:endParaRPr lang="en-US" dirty="0"/>
           </a:p>
@@ -6540,7 +6580,7 @@
             <a:fld id="{B61BEF0D-F0BB-DE4B-95CE-6DB70DBA9567}" type="datetimeFigureOut">
               <a:rPr lang="en-US" dirty="0"/>
               <a:pPr/>
-              <a:t>11/19/2018</a:t>
+              <a:t>5/17/2025</a:t>
             </a:fld>
             <a:endParaRPr lang="en-US" dirty="0"/>
           </a:p>
@@ -6655,7 +6695,7 @@
             <a:fld id="{B61BEF0D-F0BB-DE4B-95CE-6DB70DBA9567}" type="datetimeFigureOut">
               <a:rPr lang="en-US" dirty="0"/>
               <a:pPr/>
-              <a:t>11/19/2018</a:t>
+              <a:t>5/17/2025</a:t>
             </a:fld>
             <a:endParaRPr lang="en-US" dirty="0"/>
           </a:p>
@@ -6747,7 +6787,7 @@
             <a:fld id="{B61BEF0D-F0BB-DE4B-95CE-6DB70DBA9567}" type="datetimeFigureOut">
               <a:rPr lang="en-US" dirty="0"/>
               <a:pPr/>
-              <a:t>11/19/2018</a:t>
+              <a:t>5/17/2025</a:t>
             </a:fld>
             <a:endParaRPr lang="en-US" dirty="0"/>
           </a:p>
@@ -6999,7 +7039,7 @@
             <a:fld id="{B61BEF0D-F0BB-DE4B-95CE-6DB70DBA9567}" type="datetimeFigureOut">
               <a:rPr lang="en-US" dirty="0"/>
               <a:pPr/>
-              <a:t>11/19/2018</a:t>
+              <a:t>5/17/2025</a:t>
             </a:fld>
             <a:endParaRPr lang="en-US" dirty="0"/>
           </a:p>
@@ -7279,7 +7319,7 @@
             <a:fld id="{B61BEF0D-F0BB-DE4B-95CE-6DB70DBA9567}" type="datetimeFigureOut">
               <a:rPr lang="en-US" dirty="0"/>
               <a:pPr/>
-              <a:t>11/19/2018</a:t>
+              <a:t>5/17/2025</a:t>
             </a:fld>
             <a:endParaRPr lang="en-US" dirty="0"/>
           </a:p>
@@ -7708,7 +7748,7 @@
             <a:fld id="{B61BEF0D-F0BB-DE4B-95CE-6DB70DBA9567}" type="datetimeFigureOut">
               <a:rPr lang="en-US" dirty="0"/>
               <a:pPr/>
-              <a:t>11/19/2018</a:t>
+              <a:t>5/17/2025</a:t>
             </a:fld>
             <a:endParaRPr lang="en-US" dirty="0"/>
           </a:p>
@@ -14316,7 +14356,7 @@
                   <a:schemeClr val="bg1"/>
                 </a:solidFill>
               </a:rPr>
-              <a:t>Affirmative action programs for women</a:t>
+              <a:t>DEI/Affirmative action programs for women</a:t>
             </a:r>
           </a:p>
           <a:p>

</xml_diff>